<commit_message>
fix(defense): remove 'MASTER'S DEFENSE' label from header — keep only section name
</commit_message>
<xml_diff>
--- a/reports/AdaptiveHybridRecSys_Defense.pptx
+++ b/reports/AdaptiveHybridRecSys_Defense.pptx
@@ -2319,80 +2319,13 @@
       </p:grpSpPr>
       <p:sp>
         <p:nvSpPr>
-          <p:cNvPr id="2" name="Text 0"/>
-          <p:cNvSpPr/>
-          <p:nvPr/>
-        </p:nvSpPr>
-        <p:spPr>
-          <a:xfrm>
-            <a:off x="457200" y="228600"/>
-            <a:ext cx="10972800" cy="274320"/>
-          </a:xfrm>
-          <a:prstGeom prst="rect">
-            <a:avLst/>
-          </a:prstGeom>
-          <a:noFill/>
-          <a:ln/>
-        </p:spPr>
-        <p:txBody>
-          <a:bodyPr wrap="square" lIns="0" tIns="0" rIns="0" bIns="0" rtlCol="0" anchor="ctr"/>
-          <a:lstStyle/>
-          <a:p>
-            <a:pPr indent="0" marL="0">
-              <a:buNone/>
-            </a:pPr>
-            <a:r>
-              <a:rPr lang="en-US" sz="900" b="1" spc="400" kern="0" dirty="0">
-                <a:solidFill>
-                  <a:srgbClr val="C9A961"/>
-                </a:solidFill>
-                <a:latin typeface="Calibri" pitchFamily="34" charset="0"/>
-                <a:ea typeface="Calibri" pitchFamily="34" charset="-122"/>
-                <a:cs typeface="Calibri" pitchFamily="34" charset="-120"/>
-              </a:rPr>
-              <a:t>MASTER'S DEFENSE</a:t>
-            </a:r>
-            <a:pPr indent="0" marL="0">
-              <a:buNone/>
-            </a:pPr>
-            <a:r>
-              <a:rPr lang="en-US" sz="900" spc="400" kern="0" dirty="0">
-                <a:solidFill>
-                  <a:srgbClr val="8A8A8A"/>
-                </a:solidFill>
-                <a:latin typeface="Calibri" pitchFamily="34" charset="0"/>
-                <a:ea typeface="Calibri" pitchFamily="34" charset="-122"/>
-                <a:cs typeface="Calibri" pitchFamily="34" charset="-120"/>
-              </a:rPr>
-              <a:t>    |    </a:t>
-            </a:r>
-            <a:pPr indent="0" marL="0">
-              <a:buNone/>
-            </a:pPr>
-            <a:r>
-              <a:rPr lang="en-US" sz="900" spc="400" kern="0" dirty="0">
-                <a:solidFill>
-                  <a:srgbClr val="4A4A4A"/>
-                </a:solidFill>
-                <a:latin typeface="Calibri" pitchFamily="34" charset="0"/>
-                <a:ea typeface="Calibri" pitchFamily="34" charset="-122"/>
-                <a:cs typeface="Calibri" pitchFamily="34" charset="-120"/>
-              </a:rPr>
-              <a:t>CONTEXT &amp; PROBLEM STATEMENT</a:t>
-            </a:r>
-            <a:endParaRPr lang="en-US" sz="900" dirty="0"/>
-          </a:p>
-        </p:txBody>
-      </p:sp>
-      <p:sp>
-        <p:nvSpPr>
-          <p:cNvPr id="3" name="Shape 1"/>
-          <p:cNvSpPr/>
-          <p:nvPr/>
-        </p:nvSpPr>
-        <p:spPr>
-          <a:xfrm>
-            <a:off x="274320" y="310896"/>
+          <p:cNvPr id="2" name="Shape 0"/>
+          <p:cNvSpPr/>
+          <p:nvPr/>
+        </p:nvSpPr>
+        <p:spPr>
+          <a:xfrm>
+            <a:off x="457200" y="310896"/>
             <a:ext cx="91440" cy="91440"/>
           </a:xfrm>
           <a:prstGeom prst="ellipse">
@@ -2408,6 +2341,45 @@
             <a:prstDash val="solid"/>
           </a:ln>
         </p:spPr>
+      </p:sp>
+      <p:sp>
+        <p:nvSpPr>
+          <p:cNvPr id="3" name="Text 1"/>
+          <p:cNvSpPr/>
+          <p:nvPr/>
+        </p:nvSpPr>
+        <p:spPr>
+          <a:xfrm>
+            <a:off x="640080" y="228600"/>
+            <a:ext cx="10972800" cy="274320"/>
+          </a:xfrm>
+          <a:prstGeom prst="rect">
+            <a:avLst/>
+          </a:prstGeom>
+          <a:noFill/>
+          <a:ln/>
+        </p:spPr>
+        <p:txBody>
+          <a:bodyPr wrap="square" lIns="0" tIns="0" rIns="0" bIns="0" rtlCol="0" anchor="ctr"/>
+          <a:lstStyle/>
+          <a:p>
+            <a:pPr indent="0" marL="0">
+              <a:buNone/>
+            </a:pPr>
+            <a:r>
+              <a:rPr lang="en-US" sz="900" b="1" spc="400" kern="0" dirty="0">
+                <a:solidFill>
+                  <a:srgbClr val="C9A961"/>
+                </a:solidFill>
+                <a:latin typeface="Calibri" pitchFamily="34" charset="0"/>
+                <a:ea typeface="Calibri" pitchFamily="34" charset="-122"/>
+                <a:cs typeface="Calibri" pitchFamily="34" charset="-120"/>
+              </a:rPr>
+              <a:t>CONTEXT &amp; PROBLEM STATEMENT</a:t>
+            </a:r>
+            <a:endParaRPr lang="en-US" sz="900" dirty="0"/>
+          </a:p>
+        </p:txBody>
       </p:sp>
       <p:sp>
         <p:nvSpPr>
@@ -2998,80 +2970,13 @@
       </p:grpSpPr>
       <p:sp>
         <p:nvSpPr>
-          <p:cNvPr id="2" name="Text 0"/>
-          <p:cNvSpPr/>
-          <p:nvPr/>
-        </p:nvSpPr>
-        <p:spPr>
-          <a:xfrm>
-            <a:off x="457200" y="228600"/>
-            <a:ext cx="10972800" cy="274320"/>
-          </a:xfrm>
-          <a:prstGeom prst="rect">
-            <a:avLst/>
-          </a:prstGeom>
-          <a:noFill/>
-          <a:ln/>
-        </p:spPr>
-        <p:txBody>
-          <a:bodyPr wrap="square" lIns="0" tIns="0" rIns="0" bIns="0" rtlCol="0" anchor="ctr"/>
-          <a:lstStyle/>
-          <a:p>
-            <a:pPr indent="0" marL="0">
-              <a:buNone/>
-            </a:pPr>
-            <a:r>
-              <a:rPr lang="en-US" sz="900" b="1" spc="400" kern="0" dirty="0">
-                <a:solidFill>
-                  <a:srgbClr val="C9A961"/>
-                </a:solidFill>
-                <a:latin typeface="Calibri" pitchFamily="34" charset="0"/>
-                <a:ea typeface="Calibri" pitchFamily="34" charset="-122"/>
-                <a:cs typeface="Calibri" pitchFamily="34" charset="-120"/>
-              </a:rPr>
-              <a:t>MASTER'S DEFENSE</a:t>
-            </a:r>
-            <a:pPr indent="0" marL="0">
-              <a:buNone/>
-            </a:pPr>
-            <a:r>
-              <a:rPr lang="en-US" sz="900" spc="400" kern="0" dirty="0">
-                <a:solidFill>
-                  <a:srgbClr val="8A8A8A"/>
-                </a:solidFill>
-                <a:latin typeface="Calibri" pitchFamily="34" charset="0"/>
-                <a:ea typeface="Calibri" pitchFamily="34" charset="-122"/>
-                <a:cs typeface="Calibri" pitchFamily="34" charset="-120"/>
-              </a:rPr>
-              <a:t>    |    </a:t>
-            </a:r>
-            <a:pPr indent="0" marL="0">
-              <a:buNone/>
-            </a:pPr>
-            <a:r>
-              <a:rPr lang="en-US" sz="900" spc="400" kern="0" dirty="0">
-                <a:solidFill>
-                  <a:srgbClr val="4A4A4A"/>
-                </a:solidFill>
-                <a:latin typeface="Calibri" pitchFamily="34" charset="0"/>
-                <a:ea typeface="Calibri" pitchFamily="34" charset="-122"/>
-                <a:cs typeface="Calibri" pitchFamily="34" charset="-120"/>
-              </a:rPr>
-              <a:t>DATASET &amp; PREPROCESSING</a:t>
-            </a:r>
-            <a:endParaRPr lang="en-US" sz="900" dirty="0"/>
-          </a:p>
-        </p:txBody>
-      </p:sp>
-      <p:sp>
-        <p:nvSpPr>
-          <p:cNvPr id="3" name="Shape 1"/>
-          <p:cNvSpPr/>
-          <p:nvPr/>
-        </p:nvSpPr>
-        <p:spPr>
-          <a:xfrm>
-            <a:off x="274320" y="310896"/>
+          <p:cNvPr id="2" name="Shape 0"/>
+          <p:cNvSpPr/>
+          <p:nvPr/>
+        </p:nvSpPr>
+        <p:spPr>
+          <a:xfrm>
+            <a:off x="457200" y="310896"/>
             <a:ext cx="91440" cy="91440"/>
           </a:xfrm>
           <a:prstGeom prst="ellipse">
@@ -3087,6 +2992,45 @@
             <a:prstDash val="solid"/>
           </a:ln>
         </p:spPr>
+      </p:sp>
+      <p:sp>
+        <p:nvSpPr>
+          <p:cNvPr id="3" name="Text 1"/>
+          <p:cNvSpPr/>
+          <p:nvPr/>
+        </p:nvSpPr>
+        <p:spPr>
+          <a:xfrm>
+            <a:off x="640080" y="228600"/>
+            <a:ext cx="10972800" cy="274320"/>
+          </a:xfrm>
+          <a:prstGeom prst="rect">
+            <a:avLst/>
+          </a:prstGeom>
+          <a:noFill/>
+          <a:ln/>
+        </p:spPr>
+        <p:txBody>
+          <a:bodyPr wrap="square" lIns="0" tIns="0" rIns="0" bIns="0" rtlCol="0" anchor="ctr"/>
+          <a:lstStyle/>
+          <a:p>
+            <a:pPr indent="0" marL="0">
+              <a:buNone/>
+            </a:pPr>
+            <a:r>
+              <a:rPr lang="en-US" sz="900" b="1" spc="400" kern="0" dirty="0">
+                <a:solidFill>
+                  <a:srgbClr val="C9A961"/>
+                </a:solidFill>
+                <a:latin typeface="Calibri" pitchFamily="34" charset="0"/>
+                <a:ea typeface="Calibri" pitchFamily="34" charset="-122"/>
+                <a:cs typeface="Calibri" pitchFamily="34" charset="-120"/>
+              </a:rPr>
+              <a:t>DATASET &amp; PREPROCESSING</a:t>
+            </a:r>
+            <a:endParaRPr lang="en-US" sz="900" dirty="0"/>
+          </a:p>
+        </p:txBody>
       </p:sp>
       <p:sp>
         <p:nvSpPr>
@@ -4217,80 +4161,13 @@
       </p:grpSpPr>
       <p:sp>
         <p:nvSpPr>
-          <p:cNvPr id="2" name="Text 0"/>
-          <p:cNvSpPr/>
-          <p:nvPr/>
-        </p:nvSpPr>
-        <p:spPr>
-          <a:xfrm>
-            <a:off x="457200" y="228600"/>
-            <a:ext cx="10972800" cy="274320"/>
-          </a:xfrm>
-          <a:prstGeom prst="rect">
-            <a:avLst/>
-          </a:prstGeom>
-          <a:noFill/>
-          <a:ln/>
-        </p:spPr>
-        <p:txBody>
-          <a:bodyPr wrap="square" lIns="0" tIns="0" rIns="0" bIns="0" rtlCol="0" anchor="ctr"/>
-          <a:lstStyle/>
-          <a:p>
-            <a:pPr indent="0" marL="0">
-              <a:buNone/>
-            </a:pPr>
-            <a:r>
-              <a:rPr lang="en-US" sz="900" b="1" spc="400" kern="0" dirty="0">
-                <a:solidFill>
-                  <a:srgbClr val="C9A961"/>
-                </a:solidFill>
-                <a:latin typeface="Calibri" pitchFamily="34" charset="0"/>
-                <a:ea typeface="Calibri" pitchFamily="34" charset="-122"/>
-                <a:cs typeface="Calibri" pitchFamily="34" charset="-120"/>
-              </a:rPr>
-              <a:t>MASTER'S DEFENSE</a:t>
-            </a:r>
-            <a:pPr indent="0" marL="0">
-              <a:buNone/>
-            </a:pPr>
-            <a:r>
-              <a:rPr lang="en-US" sz="900" spc="400" kern="0" dirty="0">
-                <a:solidFill>
-                  <a:srgbClr val="8A8A8A"/>
-                </a:solidFill>
-                <a:latin typeface="Calibri" pitchFamily="34" charset="0"/>
-                <a:ea typeface="Calibri" pitchFamily="34" charset="-122"/>
-                <a:cs typeface="Calibri" pitchFamily="34" charset="-120"/>
-              </a:rPr>
-              <a:t>    |    </a:t>
-            </a:r>
-            <a:pPr indent="0" marL="0">
-              <a:buNone/>
-            </a:pPr>
-            <a:r>
-              <a:rPr lang="en-US" sz="900" spc="400" kern="0" dirty="0">
-                <a:solidFill>
-                  <a:srgbClr val="4A4A4A"/>
-                </a:solidFill>
-                <a:latin typeface="Calibri" pitchFamily="34" charset="0"/>
-                <a:ea typeface="Calibri" pitchFamily="34" charset="-122"/>
-                <a:cs typeface="Calibri" pitchFamily="34" charset="-120"/>
-              </a:rPr>
-              <a:t>MODEL ARCHITECTURE</a:t>
-            </a:r>
-            <a:endParaRPr lang="en-US" sz="900" dirty="0"/>
-          </a:p>
-        </p:txBody>
-      </p:sp>
-      <p:sp>
-        <p:nvSpPr>
-          <p:cNvPr id="3" name="Shape 1"/>
-          <p:cNvSpPr/>
-          <p:nvPr/>
-        </p:nvSpPr>
-        <p:spPr>
-          <a:xfrm>
-            <a:off x="274320" y="310896"/>
+          <p:cNvPr id="2" name="Shape 0"/>
+          <p:cNvSpPr/>
+          <p:nvPr/>
+        </p:nvSpPr>
+        <p:spPr>
+          <a:xfrm>
+            <a:off x="457200" y="310896"/>
             <a:ext cx="91440" cy="91440"/>
           </a:xfrm>
           <a:prstGeom prst="ellipse">
@@ -4306,6 +4183,45 @@
             <a:prstDash val="solid"/>
           </a:ln>
         </p:spPr>
+      </p:sp>
+      <p:sp>
+        <p:nvSpPr>
+          <p:cNvPr id="3" name="Text 1"/>
+          <p:cNvSpPr/>
+          <p:nvPr/>
+        </p:nvSpPr>
+        <p:spPr>
+          <a:xfrm>
+            <a:off x="640080" y="228600"/>
+            <a:ext cx="10972800" cy="274320"/>
+          </a:xfrm>
+          <a:prstGeom prst="rect">
+            <a:avLst/>
+          </a:prstGeom>
+          <a:noFill/>
+          <a:ln/>
+        </p:spPr>
+        <p:txBody>
+          <a:bodyPr wrap="square" lIns="0" tIns="0" rIns="0" bIns="0" rtlCol="0" anchor="ctr"/>
+          <a:lstStyle/>
+          <a:p>
+            <a:pPr indent="0" marL="0">
+              <a:buNone/>
+            </a:pPr>
+            <a:r>
+              <a:rPr lang="en-US" sz="900" b="1" spc="400" kern="0" dirty="0">
+                <a:solidFill>
+                  <a:srgbClr val="C9A961"/>
+                </a:solidFill>
+                <a:latin typeface="Calibri" pitchFamily="34" charset="0"/>
+                <a:ea typeface="Calibri" pitchFamily="34" charset="-122"/>
+                <a:cs typeface="Calibri" pitchFamily="34" charset="-120"/>
+              </a:rPr>
+              <a:t>MODEL ARCHITECTURE</a:t>
+            </a:r>
+            <a:endParaRPr lang="en-US" sz="900" dirty="0"/>
+          </a:p>
+        </p:txBody>
       </p:sp>
       <p:sp>
         <p:nvSpPr>
@@ -5214,80 +5130,13 @@
       </p:grpSpPr>
       <p:sp>
         <p:nvSpPr>
-          <p:cNvPr id="2" name="Text 0"/>
-          <p:cNvSpPr/>
-          <p:nvPr/>
-        </p:nvSpPr>
-        <p:spPr>
-          <a:xfrm>
-            <a:off x="457200" y="228600"/>
-            <a:ext cx="10972800" cy="274320"/>
-          </a:xfrm>
-          <a:prstGeom prst="rect">
-            <a:avLst/>
-          </a:prstGeom>
-          <a:noFill/>
-          <a:ln/>
-        </p:spPr>
-        <p:txBody>
-          <a:bodyPr wrap="square" lIns="0" tIns="0" rIns="0" bIns="0" rtlCol="0" anchor="ctr"/>
-          <a:lstStyle/>
-          <a:p>
-            <a:pPr indent="0" marL="0">
-              <a:buNone/>
-            </a:pPr>
-            <a:r>
-              <a:rPr lang="en-US" sz="900" b="1" spc="400" kern="0" dirty="0">
-                <a:solidFill>
-                  <a:srgbClr val="C9A961"/>
-                </a:solidFill>
-                <a:latin typeface="Calibri" pitchFamily="34" charset="0"/>
-                <a:ea typeface="Calibri" pitchFamily="34" charset="-122"/>
-                <a:cs typeface="Calibri" pitchFamily="34" charset="-120"/>
-              </a:rPr>
-              <a:t>MASTER'S DEFENSE</a:t>
-            </a:r>
-            <a:pPr indent="0" marL="0">
-              <a:buNone/>
-            </a:pPr>
-            <a:r>
-              <a:rPr lang="en-US" sz="900" spc="400" kern="0" dirty="0">
-                <a:solidFill>
-                  <a:srgbClr val="8A8A8A"/>
-                </a:solidFill>
-                <a:latin typeface="Calibri" pitchFamily="34" charset="0"/>
-                <a:ea typeface="Calibri" pitchFamily="34" charset="-122"/>
-                <a:cs typeface="Calibri" pitchFamily="34" charset="-120"/>
-              </a:rPr>
-              <a:t>    |    </a:t>
-            </a:r>
-            <a:pPr indent="0" marL="0">
-              <a:buNone/>
-            </a:pPr>
-            <a:r>
-              <a:rPr lang="en-US" sz="900" spc="400" kern="0" dirty="0">
-                <a:solidFill>
-                  <a:srgbClr val="4A4A4A"/>
-                </a:solidFill>
-                <a:latin typeface="Calibri" pitchFamily="34" charset="0"/>
-                <a:ea typeface="Calibri" pitchFamily="34" charset="-122"/>
-                <a:cs typeface="Calibri" pitchFamily="34" charset="-120"/>
-              </a:rPr>
-              <a:t>TRAINING &amp; v1 RESULTS</a:t>
-            </a:r>
-            <a:endParaRPr lang="en-US" sz="900" dirty="0"/>
-          </a:p>
-        </p:txBody>
-      </p:sp>
-      <p:sp>
-        <p:nvSpPr>
-          <p:cNvPr id="3" name="Shape 1"/>
-          <p:cNvSpPr/>
-          <p:nvPr/>
-        </p:nvSpPr>
-        <p:spPr>
-          <a:xfrm>
-            <a:off x="274320" y="310896"/>
+          <p:cNvPr id="2" name="Shape 0"/>
+          <p:cNvSpPr/>
+          <p:nvPr/>
+        </p:nvSpPr>
+        <p:spPr>
+          <a:xfrm>
+            <a:off x="457200" y="310896"/>
             <a:ext cx="91440" cy="91440"/>
           </a:xfrm>
           <a:prstGeom prst="ellipse">
@@ -5303,6 +5152,45 @@
             <a:prstDash val="solid"/>
           </a:ln>
         </p:spPr>
+      </p:sp>
+      <p:sp>
+        <p:nvSpPr>
+          <p:cNvPr id="3" name="Text 1"/>
+          <p:cNvSpPr/>
+          <p:nvPr/>
+        </p:nvSpPr>
+        <p:spPr>
+          <a:xfrm>
+            <a:off x="640080" y="228600"/>
+            <a:ext cx="10972800" cy="274320"/>
+          </a:xfrm>
+          <a:prstGeom prst="rect">
+            <a:avLst/>
+          </a:prstGeom>
+          <a:noFill/>
+          <a:ln/>
+        </p:spPr>
+        <p:txBody>
+          <a:bodyPr wrap="square" lIns="0" tIns="0" rIns="0" bIns="0" rtlCol="0" anchor="ctr"/>
+          <a:lstStyle/>
+          <a:p>
+            <a:pPr indent="0" marL="0">
+              <a:buNone/>
+            </a:pPr>
+            <a:r>
+              <a:rPr lang="en-US" sz="900" b="1" spc="400" kern="0" dirty="0">
+                <a:solidFill>
+                  <a:srgbClr val="C9A961"/>
+                </a:solidFill>
+                <a:latin typeface="Calibri" pitchFamily="34" charset="0"/>
+                <a:ea typeface="Calibri" pitchFamily="34" charset="-122"/>
+                <a:cs typeface="Calibri" pitchFamily="34" charset="-120"/>
+              </a:rPr>
+              <a:t>TRAINING &amp; v1 RESULTS</a:t>
+            </a:r>
+            <a:endParaRPr lang="en-US" sz="900" dirty="0"/>
+          </a:p>
+        </p:txBody>
       </p:sp>
       <p:sp>
         <p:nvSpPr>
@@ -6123,80 +6011,13 @@
       </p:grpSpPr>
       <p:sp>
         <p:nvSpPr>
-          <p:cNvPr id="2" name="Text 0"/>
-          <p:cNvSpPr/>
-          <p:nvPr/>
-        </p:nvSpPr>
-        <p:spPr>
-          <a:xfrm>
-            <a:off x="457200" y="228600"/>
-            <a:ext cx="10972800" cy="274320"/>
-          </a:xfrm>
-          <a:prstGeom prst="rect">
-            <a:avLst/>
-          </a:prstGeom>
-          <a:noFill/>
-          <a:ln/>
-        </p:spPr>
-        <p:txBody>
-          <a:bodyPr wrap="square" lIns="0" tIns="0" rIns="0" bIns="0" rtlCol="0" anchor="ctr"/>
-          <a:lstStyle/>
-          <a:p>
-            <a:pPr indent="0" marL="0">
-              <a:buNone/>
-            </a:pPr>
-            <a:r>
-              <a:rPr lang="en-US" sz="900" b="1" spc="400" kern="0" dirty="0">
-                <a:solidFill>
-                  <a:srgbClr val="C9A961"/>
-                </a:solidFill>
-                <a:latin typeface="Calibri" pitchFamily="34" charset="0"/>
-                <a:ea typeface="Calibri" pitchFamily="34" charset="-122"/>
-                <a:cs typeface="Calibri" pitchFamily="34" charset="-120"/>
-              </a:rPr>
-              <a:t>MASTER'S DEFENSE</a:t>
-            </a:r>
-            <a:pPr indent="0" marL="0">
-              <a:buNone/>
-            </a:pPr>
-            <a:r>
-              <a:rPr lang="en-US" sz="900" spc="400" kern="0" dirty="0">
-                <a:solidFill>
-                  <a:srgbClr val="8A8A8A"/>
-                </a:solidFill>
-                <a:latin typeface="Calibri" pitchFamily="34" charset="0"/>
-                <a:ea typeface="Calibri" pitchFamily="34" charset="-122"/>
-                <a:cs typeface="Calibri" pitchFamily="34" charset="-120"/>
-              </a:rPr>
-              <a:t>    |    </a:t>
-            </a:r>
-            <a:pPr indent="0" marL="0">
-              <a:buNone/>
-            </a:pPr>
-            <a:r>
-              <a:rPr lang="en-US" sz="900" spc="400" kern="0" dirty="0">
-                <a:solidFill>
-                  <a:srgbClr val="4A4A4A"/>
-                </a:solidFill>
-                <a:latin typeface="Calibri" pitchFamily="34" charset="0"/>
-                <a:ea typeface="Calibri" pitchFamily="34" charset="-122"/>
-                <a:cs typeface="Calibri" pitchFamily="34" charset="-120"/>
-              </a:rPr>
-              <a:t>ABLATION STUDY</a:t>
-            </a:r>
-            <a:endParaRPr lang="en-US" sz="900" dirty="0"/>
-          </a:p>
-        </p:txBody>
-      </p:sp>
-      <p:sp>
-        <p:nvSpPr>
-          <p:cNvPr id="3" name="Shape 1"/>
-          <p:cNvSpPr/>
-          <p:nvPr/>
-        </p:nvSpPr>
-        <p:spPr>
-          <a:xfrm>
-            <a:off x="274320" y="310896"/>
+          <p:cNvPr id="2" name="Shape 0"/>
+          <p:cNvSpPr/>
+          <p:nvPr/>
+        </p:nvSpPr>
+        <p:spPr>
+          <a:xfrm>
+            <a:off x="457200" y="310896"/>
             <a:ext cx="91440" cy="91440"/>
           </a:xfrm>
           <a:prstGeom prst="ellipse">
@@ -6212,6 +6033,45 @@
             <a:prstDash val="solid"/>
           </a:ln>
         </p:spPr>
+      </p:sp>
+      <p:sp>
+        <p:nvSpPr>
+          <p:cNvPr id="3" name="Text 1"/>
+          <p:cNvSpPr/>
+          <p:nvPr/>
+        </p:nvSpPr>
+        <p:spPr>
+          <a:xfrm>
+            <a:off x="640080" y="228600"/>
+            <a:ext cx="10972800" cy="274320"/>
+          </a:xfrm>
+          <a:prstGeom prst="rect">
+            <a:avLst/>
+          </a:prstGeom>
+          <a:noFill/>
+          <a:ln/>
+        </p:spPr>
+        <p:txBody>
+          <a:bodyPr wrap="square" lIns="0" tIns="0" rIns="0" bIns="0" rtlCol="0" anchor="ctr"/>
+          <a:lstStyle/>
+          <a:p>
+            <a:pPr indent="0" marL="0">
+              <a:buNone/>
+            </a:pPr>
+            <a:r>
+              <a:rPr lang="en-US" sz="900" b="1" spc="400" kern="0" dirty="0">
+                <a:solidFill>
+                  <a:srgbClr val="C9A961"/>
+                </a:solidFill>
+                <a:latin typeface="Calibri" pitchFamily="34" charset="0"/>
+                <a:ea typeface="Calibri" pitchFamily="34" charset="-122"/>
+                <a:cs typeface="Calibri" pitchFamily="34" charset="-120"/>
+              </a:rPr>
+              <a:t>ABLATION STUDY</a:t>
+            </a:r>
+            <a:endParaRPr lang="en-US" sz="900" dirty="0"/>
+          </a:p>
+        </p:txBody>
       </p:sp>
       <p:sp>
         <p:nvSpPr>
@@ -7477,80 +7337,13 @@
       </p:grpSpPr>
       <p:sp>
         <p:nvSpPr>
-          <p:cNvPr id="2" name="Text 0"/>
-          <p:cNvSpPr/>
-          <p:nvPr/>
-        </p:nvSpPr>
-        <p:spPr>
-          <a:xfrm>
-            <a:off x="457200" y="228600"/>
-            <a:ext cx="10972800" cy="274320"/>
-          </a:xfrm>
-          <a:prstGeom prst="rect">
-            <a:avLst/>
-          </a:prstGeom>
-          <a:noFill/>
-          <a:ln/>
-        </p:spPr>
-        <p:txBody>
-          <a:bodyPr wrap="square" lIns="0" tIns="0" rIns="0" bIns="0" rtlCol="0" anchor="ctr"/>
-          <a:lstStyle/>
-          <a:p>
-            <a:pPr indent="0" marL="0">
-              <a:buNone/>
-            </a:pPr>
-            <a:r>
-              <a:rPr lang="en-US" sz="900" b="1" spc="400" kern="0" dirty="0">
-                <a:solidFill>
-                  <a:srgbClr val="C9A961"/>
-                </a:solidFill>
-                <a:latin typeface="Calibri" pitchFamily="34" charset="0"/>
-                <a:ea typeface="Calibri" pitchFamily="34" charset="-122"/>
-                <a:cs typeface="Calibri" pitchFamily="34" charset="-120"/>
-              </a:rPr>
-              <a:t>MASTER'S DEFENSE</a:t>
-            </a:r>
-            <a:pPr indent="0" marL="0">
-              <a:buNone/>
-            </a:pPr>
-            <a:r>
-              <a:rPr lang="en-US" sz="900" spc="400" kern="0" dirty="0">
-                <a:solidFill>
-                  <a:srgbClr val="8A8A8A"/>
-                </a:solidFill>
-                <a:latin typeface="Calibri" pitchFamily="34" charset="0"/>
-                <a:ea typeface="Calibri" pitchFamily="34" charset="-122"/>
-                <a:cs typeface="Calibri" pitchFamily="34" charset="-120"/>
-              </a:rPr>
-              <a:t>    |    </a:t>
-            </a:r>
-            <a:pPr indent="0" marL="0">
-              <a:buNone/>
-            </a:pPr>
-            <a:r>
-              <a:rPr lang="en-US" sz="900" spc="400" kern="0" dirty="0">
-                <a:solidFill>
-                  <a:srgbClr val="4A4A4A"/>
-                </a:solidFill>
-                <a:latin typeface="Calibri" pitchFamily="34" charset="0"/>
-                <a:ea typeface="Calibri" pitchFamily="34" charset="-122"/>
-                <a:cs typeface="Calibri" pitchFamily="34" charset="-120"/>
-              </a:rPr>
-              <a:t>DIAGNOSTIC — MODE COLLAPSE</a:t>
-            </a:r>
-            <a:endParaRPr lang="en-US" sz="900" dirty="0"/>
-          </a:p>
-        </p:txBody>
-      </p:sp>
-      <p:sp>
-        <p:nvSpPr>
-          <p:cNvPr id="3" name="Shape 1"/>
-          <p:cNvSpPr/>
-          <p:nvPr/>
-        </p:nvSpPr>
-        <p:spPr>
-          <a:xfrm>
-            <a:off x="274320" y="310896"/>
+          <p:cNvPr id="2" name="Shape 0"/>
+          <p:cNvSpPr/>
+          <p:nvPr/>
+        </p:nvSpPr>
+        <p:spPr>
+          <a:xfrm>
+            <a:off x="457200" y="310896"/>
             <a:ext cx="91440" cy="91440"/>
           </a:xfrm>
           <a:prstGeom prst="ellipse">
@@ -7566,6 +7359,45 @@
             <a:prstDash val="solid"/>
           </a:ln>
         </p:spPr>
+      </p:sp>
+      <p:sp>
+        <p:nvSpPr>
+          <p:cNvPr id="3" name="Text 1"/>
+          <p:cNvSpPr/>
+          <p:nvPr/>
+        </p:nvSpPr>
+        <p:spPr>
+          <a:xfrm>
+            <a:off x="640080" y="228600"/>
+            <a:ext cx="10972800" cy="274320"/>
+          </a:xfrm>
+          <a:prstGeom prst="rect">
+            <a:avLst/>
+          </a:prstGeom>
+          <a:noFill/>
+          <a:ln/>
+        </p:spPr>
+        <p:txBody>
+          <a:bodyPr wrap="square" lIns="0" tIns="0" rIns="0" bIns="0" rtlCol="0" anchor="ctr"/>
+          <a:lstStyle/>
+          <a:p>
+            <a:pPr indent="0" marL="0">
+              <a:buNone/>
+            </a:pPr>
+            <a:r>
+              <a:rPr lang="en-US" sz="900" b="1" spc="400" kern="0" dirty="0">
+                <a:solidFill>
+                  <a:srgbClr val="C9A961"/>
+                </a:solidFill>
+                <a:latin typeface="Calibri" pitchFamily="34" charset="0"/>
+                <a:ea typeface="Calibri" pitchFamily="34" charset="-122"/>
+                <a:cs typeface="Calibri" pitchFamily="34" charset="-120"/>
+              </a:rPr>
+              <a:t>DIAGNOSTIC — MODE COLLAPSE</a:t>
+            </a:r>
+            <a:endParaRPr lang="en-US" sz="900" dirty="0"/>
+          </a:p>
+        </p:txBody>
       </p:sp>
       <p:sp>
         <p:nvSpPr>
@@ -9100,80 +8932,13 @@
       </p:grpSpPr>
       <p:sp>
         <p:nvSpPr>
-          <p:cNvPr id="2" name="Text 0"/>
-          <p:cNvSpPr/>
-          <p:nvPr/>
-        </p:nvSpPr>
-        <p:spPr>
-          <a:xfrm>
-            <a:off x="457200" y="228600"/>
-            <a:ext cx="10972800" cy="274320"/>
-          </a:xfrm>
-          <a:prstGeom prst="rect">
-            <a:avLst/>
-          </a:prstGeom>
-          <a:noFill/>
-          <a:ln/>
-        </p:spPr>
-        <p:txBody>
-          <a:bodyPr wrap="square" lIns="0" tIns="0" rIns="0" bIns="0" rtlCol="0" anchor="ctr"/>
-          <a:lstStyle/>
-          <a:p>
-            <a:pPr indent="0" marL="0">
-              <a:buNone/>
-            </a:pPr>
-            <a:r>
-              <a:rPr lang="en-US" sz="900" b="1" spc="400" kern="0" dirty="0">
-                <a:solidFill>
-                  <a:srgbClr val="C9A961"/>
-                </a:solidFill>
-                <a:latin typeface="Calibri" pitchFamily="34" charset="0"/>
-                <a:ea typeface="Calibri" pitchFamily="34" charset="-122"/>
-                <a:cs typeface="Calibri" pitchFamily="34" charset="-120"/>
-              </a:rPr>
-              <a:t>MASTER'S DEFENSE</a:t>
-            </a:r>
-            <a:pPr indent="0" marL="0">
-              <a:buNone/>
-            </a:pPr>
-            <a:r>
-              <a:rPr lang="en-US" sz="900" spc="400" kern="0" dirty="0">
-                <a:solidFill>
-                  <a:srgbClr val="8A8A8A"/>
-                </a:solidFill>
-                <a:latin typeface="Calibri" pitchFamily="34" charset="0"/>
-                <a:ea typeface="Calibri" pitchFamily="34" charset="-122"/>
-                <a:cs typeface="Calibri" pitchFamily="34" charset="-120"/>
-              </a:rPr>
-              <a:t>    |    </a:t>
-            </a:r>
-            <a:pPr indent="0" marL="0">
-              <a:buNone/>
-            </a:pPr>
-            <a:r>
-              <a:rPr lang="en-US" sz="900" spc="400" kern="0" dirty="0">
-                <a:solidFill>
-                  <a:srgbClr val="4A4A4A"/>
-                </a:solidFill>
-                <a:latin typeface="Calibri" pitchFamily="34" charset="0"/>
-                <a:ea typeface="Calibri" pitchFamily="34" charset="-122"/>
-                <a:cs typeface="Calibri" pitchFamily="34" charset="-120"/>
-              </a:rPr>
-              <a:t>ANTI-COLLAPSE FIX — v2</a:t>
-            </a:r>
-            <a:endParaRPr lang="en-US" sz="900" dirty="0"/>
-          </a:p>
-        </p:txBody>
-      </p:sp>
-      <p:sp>
-        <p:nvSpPr>
-          <p:cNvPr id="3" name="Shape 1"/>
-          <p:cNvSpPr/>
-          <p:nvPr/>
-        </p:nvSpPr>
-        <p:spPr>
-          <a:xfrm>
-            <a:off x="274320" y="310896"/>
+          <p:cNvPr id="2" name="Shape 0"/>
+          <p:cNvSpPr/>
+          <p:nvPr/>
+        </p:nvSpPr>
+        <p:spPr>
+          <a:xfrm>
+            <a:off x="457200" y="310896"/>
             <a:ext cx="91440" cy="91440"/>
           </a:xfrm>
           <a:prstGeom prst="ellipse">
@@ -9189,6 +8954,45 @@
             <a:prstDash val="solid"/>
           </a:ln>
         </p:spPr>
+      </p:sp>
+      <p:sp>
+        <p:nvSpPr>
+          <p:cNvPr id="3" name="Text 1"/>
+          <p:cNvSpPr/>
+          <p:nvPr/>
+        </p:nvSpPr>
+        <p:spPr>
+          <a:xfrm>
+            <a:off x="640080" y="228600"/>
+            <a:ext cx="10972800" cy="274320"/>
+          </a:xfrm>
+          <a:prstGeom prst="rect">
+            <a:avLst/>
+          </a:prstGeom>
+          <a:noFill/>
+          <a:ln/>
+        </p:spPr>
+        <p:txBody>
+          <a:bodyPr wrap="square" lIns="0" tIns="0" rIns="0" bIns="0" rtlCol="0" anchor="ctr"/>
+          <a:lstStyle/>
+          <a:p>
+            <a:pPr indent="0" marL="0">
+              <a:buNone/>
+            </a:pPr>
+            <a:r>
+              <a:rPr lang="en-US" sz="900" b="1" spc="400" kern="0" dirty="0">
+                <a:solidFill>
+                  <a:srgbClr val="C9A961"/>
+                </a:solidFill>
+                <a:latin typeface="Calibri" pitchFamily="34" charset="0"/>
+                <a:ea typeface="Calibri" pitchFamily="34" charset="-122"/>
+                <a:cs typeface="Calibri" pitchFamily="34" charset="-120"/>
+              </a:rPr>
+              <a:t>ANTI-COLLAPSE FIX — v2</a:t>
+            </a:r>
+            <a:endParaRPr lang="en-US" sz="900" dirty="0"/>
+          </a:p>
+        </p:txBody>
       </p:sp>
       <p:sp>
         <p:nvSpPr>
@@ -9959,80 +9763,13 @@
       </p:grpSpPr>
       <p:sp>
         <p:nvSpPr>
-          <p:cNvPr id="2" name="Text 0"/>
-          <p:cNvSpPr/>
-          <p:nvPr/>
-        </p:nvSpPr>
-        <p:spPr>
-          <a:xfrm>
-            <a:off x="457200" y="228600"/>
-            <a:ext cx="10972800" cy="274320"/>
-          </a:xfrm>
-          <a:prstGeom prst="rect">
-            <a:avLst/>
-          </a:prstGeom>
-          <a:noFill/>
-          <a:ln/>
-        </p:spPr>
-        <p:txBody>
-          <a:bodyPr wrap="square" lIns="0" tIns="0" rIns="0" bIns="0" rtlCol="0" anchor="ctr"/>
-          <a:lstStyle/>
-          <a:p>
-            <a:pPr indent="0" marL="0">
-              <a:buNone/>
-            </a:pPr>
-            <a:r>
-              <a:rPr lang="en-US" sz="900" b="1" spc="400" kern="0" dirty="0">
-                <a:solidFill>
-                  <a:srgbClr val="C9A961"/>
-                </a:solidFill>
-                <a:latin typeface="Calibri" pitchFamily="34" charset="0"/>
-                <a:ea typeface="Calibri" pitchFamily="34" charset="-122"/>
-                <a:cs typeface="Calibri" pitchFamily="34" charset="-120"/>
-              </a:rPr>
-              <a:t>MASTER'S DEFENSE</a:t>
-            </a:r>
-            <a:pPr indent="0" marL="0">
-              <a:buNone/>
-            </a:pPr>
-            <a:r>
-              <a:rPr lang="en-US" sz="900" spc="400" kern="0" dirty="0">
-                <a:solidFill>
-                  <a:srgbClr val="8A8A8A"/>
-                </a:solidFill>
-                <a:latin typeface="Calibri" pitchFamily="34" charset="0"/>
-                <a:ea typeface="Calibri" pitchFamily="34" charset="-122"/>
-                <a:cs typeface="Calibri" pitchFamily="34" charset="-120"/>
-              </a:rPr>
-              <a:t>    |    </a:t>
-            </a:r>
-            <a:pPr indent="0" marL="0">
-              <a:buNone/>
-            </a:pPr>
-            <a:r>
-              <a:rPr lang="en-US" sz="900" spc="400" kern="0" dirty="0">
-                <a:solidFill>
-                  <a:srgbClr val="4A4A4A"/>
-                </a:solidFill>
-                <a:latin typeface="Calibri" pitchFamily="34" charset="0"/>
-                <a:ea typeface="Calibri" pitchFamily="34" charset="-122"/>
-                <a:cs typeface="Calibri" pitchFamily="34" charset="-120"/>
-              </a:rPr>
-              <a:t>CONCLUSION &amp; FUTURE WORK</a:t>
-            </a:r>
-            <a:endParaRPr lang="en-US" sz="900" dirty="0"/>
-          </a:p>
-        </p:txBody>
-      </p:sp>
-      <p:sp>
-        <p:nvSpPr>
-          <p:cNvPr id="3" name="Shape 1"/>
-          <p:cNvSpPr/>
-          <p:nvPr/>
-        </p:nvSpPr>
-        <p:spPr>
-          <a:xfrm>
-            <a:off x="274320" y="310896"/>
+          <p:cNvPr id="2" name="Shape 0"/>
+          <p:cNvSpPr/>
+          <p:nvPr/>
+        </p:nvSpPr>
+        <p:spPr>
+          <a:xfrm>
+            <a:off x="457200" y="310896"/>
             <a:ext cx="91440" cy="91440"/>
           </a:xfrm>
           <a:prstGeom prst="ellipse">
@@ -10048,6 +9785,45 @@
             <a:prstDash val="solid"/>
           </a:ln>
         </p:spPr>
+      </p:sp>
+      <p:sp>
+        <p:nvSpPr>
+          <p:cNvPr id="3" name="Text 1"/>
+          <p:cNvSpPr/>
+          <p:nvPr/>
+        </p:nvSpPr>
+        <p:spPr>
+          <a:xfrm>
+            <a:off x="640080" y="228600"/>
+            <a:ext cx="10972800" cy="274320"/>
+          </a:xfrm>
+          <a:prstGeom prst="rect">
+            <a:avLst/>
+          </a:prstGeom>
+          <a:noFill/>
+          <a:ln/>
+        </p:spPr>
+        <p:txBody>
+          <a:bodyPr wrap="square" lIns="0" tIns="0" rIns="0" bIns="0" rtlCol="0" anchor="ctr"/>
+          <a:lstStyle/>
+          <a:p>
+            <a:pPr indent="0" marL="0">
+              <a:buNone/>
+            </a:pPr>
+            <a:r>
+              <a:rPr lang="en-US" sz="900" b="1" spc="400" kern="0" dirty="0">
+                <a:solidFill>
+                  <a:srgbClr val="C9A961"/>
+                </a:solidFill>
+                <a:latin typeface="Calibri" pitchFamily="34" charset="0"/>
+                <a:ea typeface="Calibri" pitchFamily="34" charset="-122"/>
+                <a:cs typeface="Calibri" pitchFamily="34" charset="-120"/>
+              </a:rPr>
+              <a:t>CONCLUSION &amp; FUTURE WORK</a:t>
+            </a:r>
+            <a:endParaRPr lang="en-US" sz="900" dirty="0"/>
+          </a:p>
+        </p:txBody>
       </p:sp>
       <p:sp>
         <p:nvSpPr>

</xml_diff>

<commit_message>
feat(defense): minimalist cover slide + comprehensive speaker notes
- Cover slide redesigned: cream background, no gold bars, no bottom footer text
- Added Defense_Speaker_Notes.md with ~8-10 min speech for all 9 slides
- Includes 8 anticipated committee questions with prepared answers
- Mobile-friendly markdown for reading on phone before defense
</commit_message>
<xml_diff>
--- a/reports/AdaptiveHybridRecSys_Defense.pptx
+++ b/reports/AdaptiveHybridRecSys_Defense.pptx
@@ -1569,7 +1569,7 @@
     <p:bg>
       <p:bgPr>
         <a:solidFill>
-          <a:srgbClr val="1E2761"/>
+          <a:srgbClr val="F5F1E8"/>
         </a:solidFill>
       </p:bgPr>
     </p:bg>
@@ -1587,59 +1587,9 @@
           <a:chExt cx="0" cy="0"/>
         </a:xfrm>
       </p:grpSpPr>
-      <p:sp>
-        <p:nvSpPr>
-          <p:cNvPr id="2" name="Shape 0"/>
-          <p:cNvSpPr/>
-          <p:nvPr/>
-        </p:nvSpPr>
-        <p:spPr>
-          <a:xfrm>
-            <a:off x="0" y="0"/>
-            <a:ext cx="12161520" cy="274320"/>
-          </a:xfrm>
-          <a:prstGeom prst="rect">
-            <a:avLst/>
-          </a:prstGeom>
-          <a:solidFill>
-            <a:srgbClr val="C9A961"/>
-          </a:solidFill>
-          <a:ln w="12700">
-            <a:solidFill>
-              <a:srgbClr val="C9A961"/>
-            </a:solidFill>
-            <a:prstDash val="solid"/>
-          </a:ln>
-        </p:spPr>
-      </p:sp>
-      <p:sp>
-        <p:nvSpPr>
-          <p:cNvPr id="3" name="Shape 1"/>
-          <p:cNvSpPr/>
-          <p:nvPr/>
-        </p:nvSpPr>
-        <p:spPr>
-          <a:xfrm>
-            <a:off x="0" y="6583680"/>
-            <a:ext cx="12161520" cy="274320"/>
-          </a:xfrm>
-          <a:prstGeom prst="rect">
-            <a:avLst/>
-          </a:prstGeom>
-          <a:solidFill>
-            <a:srgbClr val="C9A961"/>
-          </a:solidFill>
-          <a:ln w="12700">
-            <a:solidFill>
-              <a:srgbClr val="C9A961"/>
-            </a:solidFill>
-            <a:prstDash val="solid"/>
-          </a:ln>
-        </p:spPr>
-      </p:sp>
       <p:pic>
         <p:nvPicPr>
-          <p:cNvPr id="4" name="Image 0" descr="/tmp/figs/kaznu_logo.png">    </p:cNvPr>
+          <p:cNvPr id="2" name="Image 0" descr="/tmp/figs/kaznu_logo.png">    </p:cNvPr>
           <p:cNvPicPr>
             <a:picLocks noChangeAspect="1"/>
           </p:cNvPicPr>
@@ -1653,8 +1603,8 @@
         </p:blipFill>
         <p:spPr>
           <a:xfrm>
-            <a:off x="5349240" y="640080"/>
-            <a:ext cx="1463040" cy="1463040"/>
+            <a:off x="5532120" y="502920"/>
+            <a:ext cx="1097280" cy="1097280"/>
           </a:xfrm>
           <a:prstGeom prst="rect">
             <a:avLst/>
@@ -1663,14 +1613,14 @@
       </p:pic>
       <p:sp>
         <p:nvSpPr>
-          <p:cNvPr id="5" name="Text 2"/>
-          <p:cNvSpPr/>
-          <p:nvPr/>
-        </p:nvSpPr>
-        <p:spPr>
-          <a:xfrm>
-            <a:off x="457200" y="2194560"/>
-            <a:ext cx="11247120" cy="365760"/>
+          <p:cNvPr id="3" name="Text 0"/>
+          <p:cNvSpPr/>
+          <p:nvPr/>
+        </p:nvSpPr>
+        <p:spPr>
+          <a:xfrm>
+            <a:off x="457200" y="1737360"/>
+            <a:ext cx="11247120" cy="320040"/>
           </a:xfrm>
           <a:prstGeom prst="rect">
             <a:avLst/>
@@ -1686,30 +1636,133 @@
               <a:buNone/>
             </a:pPr>
             <a:r>
-              <a:rPr lang="en-US" sz="1400" b="1" spc="600" kern="0" dirty="0">
+              <a:rPr lang="en-US" sz="1100" b="1" spc="800" kern="0" dirty="0">
                 <a:solidFill>
                   <a:srgbClr val="C9A961"/>
+                </a:solidFill>
+                <a:latin typeface="Calibri" pitchFamily="34" charset="0"/>
+                <a:ea typeface="Calibri" pitchFamily="34" charset="-122"/>
+                <a:cs typeface="Calibri" pitchFamily="34" charset="-120"/>
+              </a:rPr>
+              <a:t>AL-FARABI KAZAKH NATIONAL UNIVERSITY</a:t>
+            </a:r>
+            <a:endParaRPr lang="en-US" sz="1100" dirty="0"/>
+          </a:p>
+        </p:txBody>
+      </p:sp>
+      <p:sp>
+        <p:nvSpPr>
+          <p:cNvPr id="4" name="Text 1"/>
+          <p:cNvSpPr/>
+          <p:nvPr/>
+        </p:nvSpPr>
+        <p:spPr>
+          <a:xfrm>
+            <a:off x="457200" y="2057400"/>
+            <a:ext cx="11247120" cy="274320"/>
+          </a:xfrm>
+          <a:prstGeom prst="rect">
+            <a:avLst/>
+          </a:prstGeom>
+          <a:noFill/>
+          <a:ln/>
+        </p:spPr>
+        <p:txBody>
+          <a:bodyPr wrap="square" lIns="0" tIns="0" rIns="0" bIns="0" rtlCol="0" anchor="ctr"/>
+          <a:lstStyle/>
+          <a:p>
+            <a:pPr algn="ctr" indent="0" marL="0">
+              <a:buNone/>
+            </a:pPr>
+            <a:r>
+              <a:rPr lang="en-US" sz="1000" i="1" dirty="0">
+                <a:solidFill>
+                  <a:srgbClr val="8A8A8A"/>
+                </a:solidFill>
+                <a:latin typeface="Calibri" pitchFamily="34" charset="0"/>
+                <a:ea typeface="Calibri" pitchFamily="34" charset="-122"/>
+                <a:cs typeface="Calibri" pitchFamily="34" charset="-120"/>
+              </a:rPr>
+              <a:t>Faculty of Information Technologies and Artificial Intelligence</a:t>
+            </a:r>
+            <a:endParaRPr lang="en-US" sz="1000" dirty="0"/>
+          </a:p>
+        </p:txBody>
+      </p:sp>
+      <p:sp>
+        <p:nvSpPr>
+          <p:cNvPr id="5" name="Shape 2"/>
+          <p:cNvSpPr/>
+          <p:nvPr/>
+        </p:nvSpPr>
+        <p:spPr>
+          <a:xfrm>
+            <a:off x="5623560" y="2468880"/>
+            <a:ext cx="914400" cy="22860"/>
+          </a:xfrm>
+          <a:prstGeom prst="rect">
+            <a:avLst/>
+          </a:prstGeom>
+          <a:solidFill>
+            <a:srgbClr val="C9A961"/>
+          </a:solidFill>
+          <a:ln w="12700">
+            <a:solidFill>
+              <a:srgbClr val="C9A961"/>
+            </a:solidFill>
+            <a:prstDash val="solid"/>
+          </a:ln>
+        </p:spPr>
+      </p:sp>
+      <p:sp>
+        <p:nvSpPr>
+          <p:cNvPr id="6" name="Text 3"/>
+          <p:cNvSpPr/>
+          <p:nvPr/>
+        </p:nvSpPr>
+        <p:spPr>
+          <a:xfrm>
+            <a:off x="457200" y="2834640"/>
+            <a:ext cx="11247120" cy="640080"/>
+          </a:xfrm>
+          <a:prstGeom prst="rect">
+            <a:avLst/>
+          </a:prstGeom>
+          <a:noFill/>
+          <a:ln/>
+        </p:spPr>
+        <p:txBody>
+          <a:bodyPr wrap="square" lIns="0" tIns="0" rIns="0" bIns="0" rtlCol="0" anchor="ctr"/>
+          <a:lstStyle/>
+          <a:p>
+            <a:pPr algn="ctr" indent="0" marL="0">
+              <a:buNone/>
+            </a:pPr>
+            <a:r>
+              <a:rPr lang="en-US" sz="4200" b="1" dirty="0">
+                <a:solidFill>
+                  <a:srgbClr val="1E2761"/>
                 </a:solidFill>
                 <a:latin typeface="Georgia" pitchFamily="34" charset="0"/>
                 <a:ea typeface="Georgia" pitchFamily="34" charset="-122"/>
                 <a:cs typeface="Georgia" pitchFamily="34" charset="-120"/>
               </a:rPr>
-              <a:t>AL-FARABI KAZAKH NATIONAL UNIVERSITY</a:t>
-            </a:r>
-            <a:endParaRPr lang="en-US" sz="1400" dirty="0"/>
-          </a:p>
-        </p:txBody>
-      </p:sp>
-      <p:sp>
-        <p:nvSpPr>
-          <p:cNvPr id="6" name="Text 3"/>
-          <p:cNvSpPr/>
-          <p:nvPr/>
-        </p:nvSpPr>
-        <p:spPr>
-          <a:xfrm>
-            <a:off x="457200" y="2542032"/>
-            <a:ext cx="11247120" cy="274320"/>
+              <a:t>Adaptive Hybrid Recommendation</a:t>
+            </a:r>
+            <a:endParaRPr lang="en-US" sz="4200" dirty="0"/>
+          </a:p>
+        </p:txBody>
+      </p:sp>
+      <p:sp>
+        <p:nvSpPr>
+          <p:cNvPr id="7" name="Text 4"/>
+          <p:cNvSpPr/>
+          <p:nvPr/>
+        </p:nvSpPr>
+        <p:spPr>
+          <a:xfrm>
+            <a:off x="457200" y="3429000"/>
+            <a:ext cx="11247120" cy="640080"/>
           </a:xfrm>
           <a:prstGeom prst="rect">
             <a:avLst/>
@@ -1725,56 +1778,17 @@
               <a:buNone/>
             </a:pPr>
             <a:r>
-              <a:rPr lang="en-US" sz="1100" i="1" dirty="0">
-                <a:solidFill>
-                  <a:srgbClr val="E8D9A8"/>
-                </a:solidFill>
-                <a:latin typeface="Calibri" pitchFamily="34" charset="0"/>
-                <a:ea typeface="Calibri" pitchFamily="34" charset="-122"/>
-                <a:cs typeface="Calibri" pitchFamily="34" charset="-120"/>
-              </a:rPr>
-              <a:t>Faculty of Information Technologies and Artificial Intelligence  ·  Department of Computer Science</a:t>
-            </a:r>
-            <a:endParaRPr lang="en-US" sz="1100" dirty="0"/>
-          </a:p>
-        </p:txBody>
-      </p:sp>
-      <p:sp>
-        <p:nvSpPr>
-          <p:cNvPr id="7" name="Text 4"/>
-          <p:cNvSpPr/>
-          <p:nvPr/>
-        </p:nvSpPr>
-        <p:spPr>
-          <a:xfrm>
-            <a:off x="457200" y="3017520"/>
-            <a:ext cx="11247120" cy="548640"/>
-          </a:xfrm>
-          <a:prstGeom prst="rect">
-            <a:avLst/>
-          </a:prstGeom>
-          <a:noFill/>
-          <a:ln/>
-        </p:spPr>
-        <p:txBody>
-          <a:bodyPr wrap="square" lIns="0" tIns="0" rIns="0" bIns="0" rtlCol="0" anchor="ctr"/>
-          <a:lstStyle/>
-          <a:p>
-            <a:pPr algn="ctr" indent="0" marL="0">
-              <a:buNone/>
-            </a:pPr>
-            <a:r>
-              <a:rPr lang="en-US" sz="3800" b="1" dirty="0">
-                <a:solidFill>
-                  <a:srgbClr val="FFFFFF"/>
+              <a:rPr lang="en-US" sz="3200" b="1" dirty="0">
+                <a:solidFill>
+                  <a:srgbClr val="1E2761"/>
                 </a:solidFill>
                 <a:latin typeface="Georgia" pitchFamily="34" charset="0"/>
                 <a:ea typeface="Georgia" pitchFamily="34" charset="-122"/>
                 <a:cs typeface="Georgia" pitchFamily="34" charset="-120"/>
               </a:rPr>
-              <a:t>Adaptive Hybrid Recommendation</a:t>
-            </a:r>
-            <a:endParaRPr lang="en-US" sz="3800" dirty="0"/>
+              <a:t>System with Context-Aware Attention Fusion</a:t>
+            </a:r>
+            <a:endParaRPr lang="en-US" sz="3200" dirty="0"/>
           </a:p>
         </p:txBody>
       </p:sp>
@@ -1786,8 +1800,8 @@
         </p:nvSpPr>
         <p:spPr>
           <a:xfrm>
-            <a:off x="457200" y="3520440"/>
-            <a:ext cx="11247120" cy="548640"/>
+            <a:off x="457200" y="4206240"/>
+            <a:ext cx="11247120" cy="365760"/>
           </a:xfrm>
           <a:prstGeom prst="rect">
             <a:avLst/>
@@ -1803,17 +1817,17 @@
               <a:buNone/>
             </a:pPr>
             <a:r>
-              <a:rPr lang="en-US" sz="3000" b="1" dirty="0">
-                <a:solidFill>
-                  <a:srgbClr val="FFFFFF"/>
+              <a:rPr lang="en-US" sz="1400" i="1" dirty="0">
+                <a:solidFill>
+                  <a:srgbClr val="4A4A4A"/>
                 </a:solidFill>
                 <a:latin typeface="Georgia" pitchFamily="34" charset="0"/>
                 <a:ea typeface="Georgia" pitchFamily="34" charset="-122"/>
                 <a:cs typeface="Georgia" pitchFamily="34" charset="-120"/>
               </a:rPr>
-              <a:t>System with Context-Aware Attention Fusion</a:t>
-            </a:r>
-            <a:endParaRPr lang="en-US" sz="3000" dirty="0"/>
+              <a:t>Discovery &amp; Fix of Attention Gate Mode Collapse in Component-Level Fusion</a:t>
+            </a:r>
+            <a:endParaRPr lang="en-US" sz="1400" dirty="0"/>
           </a:p>
         </p:txBody>
       </p:sp>
@@ -1825,34 +1839,34 @@
         </p:nvSpPr>
         <p:spPr>
           <a:xfrm>
-            <a:off x="457200" y="4160520"/>
-            <a:ext cx="11247120" cy="365760"/>
-          </a:xfrm>
-          <a:prstGeom prst="rect">
-            <a:avLst/>
-          </a:prstGeom>
-          <a:noFill/>
-          <a:ln/>
-        </p:spPr>
-        <p:txBody>
-          <a:bodyPr wrap="square" lIns="0" tIns="0" rIns="0" bIns="0" rtlCol="0" anchor="ctr"/>
-          <a:lstStyle/>
-          <a:p>
-            <a:pPr algn="ctr" indent="0" marL="0">
-              <a:buNone/>
-            </a:pPr>
-            <a:r>
-              <a:rPr lang="en-US" sz="1500" i="1" dirty="0">
-                <a:solidFill>
-                  <a:srgbClr val="E8D9A8"/>
-                </a:solidFill>
-                <a:latin typeface="Georgia" pitchFamily="34" charset="0"/>
-                <a:ea typeface="Georgia" pitchFamily="34" charset="-122"/>
-                <a:cs typeface="Georgia" pitchFamily="34" charset="-120"/>
-              </a:rPr>
-              <a:t>Discovery &amp; Fix of Attention Gate Mode Collapse in Component-Level Fusion</a:t>
-            </a:r>
-            <a:endParaRPr lang="en-US" sz="1500" dirty="0"/>
+            <a:off x="2286000" y="5029200"/>
+            <a:ext cx="3383280" cy="347472"/>
+          </a:xfrm>
+          <a:prstGeom prst="rect">
+            <a:avLst/>
+          </a:prstGeom>
+          <a:noFill/>
+          <a:ln/>
+        </p:spPr>
+        <p:txBody>
+          <a:bodyPr wrap="square" lIns="0" tIns="0" rIns="0" bIns="0" rtlCol="0" anchor="ctr"/>
+          <a:lstStyle/>
+          <a:p>
+            <a:pPr algn="r" indent="0" marL="0">
+              <a:buNone/>
+            </a:pPr>
+            <a:r>
+              <a:rPr lang="en-US" sz="1100" b="1" spc="200" kern="0" dirty="0">
+                <a:solidFill>
+                  <a:srgbClr val="C9A961"/>
+                </a:solidFill>
+                <a:latin typeface="Calibri" pitchFamily="34" charset="0"/>
+                <a:ea typeface="Calibri" pitchFamily="34" charset="-122"/>
+                <a:cs typeface="Calibri" pitchFamily="34" charset="-120"/>
+              </a:rPr>
+              <a:t>Master's Candidate</a:t>
+            </a:r>
+            <a:endParaRPr lang="en-US" sz="1100" dirty="0"/>
           </a:p>
         </p:txBody>
       </p:sp>
@@ -1864,7 +1878,46 @@
         </p:nvSpPr>
         <p:spPr>
           <a:xfrm>
-            <a:off x="2560320" y="4572000"/>
+            <a:off x="5852160" y="5029200"/>
+            <a:ext cx="5029200" cy="347472"/>
+          </a:xfrm>
+          <a:prstGeom prst="rect">
+            <a:avLst/>
+          </a:prstGeom>
+          <a:noFill/>
+          <a:ln/>
+        </p:spPr>
+        <p:txBody>
+          <a:bodyPr wrap="square" lIns="0" tIns="0" rIns="0" bIns="0" rtlCol="0" anchor="ctr"/>
+          <a:lstStyle/>
+          <a:p>
+            <a:pPr algn="l" indent="0" marL="0">
+              <a:buNone/>
+            </a:pPr>
+            <a:r>
+              <a:rPr lang="en-US" sz="1100" dirty="0">
+                <a:solidFill>
+                  <a:srgbClr val="1A1A1A"/>
+                </a:solidFill>
+                <a:latin typeface="Calibri" pitchFamily="34" charset="0"/>
+                <a:ea typeface="Calibri" pitchFamily="34" charset="-122"/>
+                <a:cs typeface="Calibri" pitchFamily="34" charset="-120"/>
+              </a:rPr>
+              <a:t>Zhumakhan Medet</a:t>
+            </a:r>
+            <a:endParaRPr lang="en-US" sz="1100" dirty="0"/>
+          </a:p>
+        </p:txBody>
+      </p:sp>
+      <p:sp>
+        <p:nvSpPr>
+          <p:cNvPr id="11" name="Text 8"/>
+          <p:cNvSpPr/>
+          <p:nvPr/>
+        </p:nvSpPr>
+        <p:spPr>
+          <a:xfrm>
+            <a:off x="2286000" y="5376672"/>
             <a:ext cx="3383280" cy="347472"/>
           </a:xfrm>
           <a:prstGeom prst="rect">
@@ -1881,7 +1934,7 @@
               <a:buNone/>
             </a:pPr>
             <a:r>
-              <a:rPr lang="en-US" sz="1200" b="1" dirty="0">
+              <a:rPr lang="en-US" sz="1100" b="1" spc="200" kern="0" dirty="0">
                 <a:solidFill>
                   <a:srgbClr val="C9A961"/>
                 </a:solidFill>
@@ -1889,21 +1942,21 @@
                 <a:ea typeface="Calibri" pitchFamily="34" charset="-122"/>
                 <a:cs typeface="Calibri" pitchFamily="34" charset="-120"/>
               </a:rPr>
-              <a:t>Master's Candidate:</a:t>
-            </a:r>
-            <a:endParaRPr lang="en-US" sz="1200" dirty="0"/>
-          </a:p>
-        </p:txBody>
-      </p:sp>
-      <p:sp>
-        <p:nvSpPr>
-          <p:cNvPr id="11" name="Text 8"/>
-          <p:cNvSpPr/>
-          <p:nvPr/>
-        </p:nvSpPr>
-        <p:spPr>
-          <a:xfrm>
-            <a:off x="6035040" y="4572000"/>
+              <a:t>Scientific Advisor</a:t>
+            </a:r>
+            <a:endParaRPr lang="en-US" sz="1100" dirty="0"/>
+          </a:p>
+        </p:txBody>
+      </p:sp>
+      <p:sp>
+        <p:nvSpPr>
+          <p:cNvPr id="12" name="Text 9"/>
+          <p:cNvSpPr/>
+          <p:nvPr/>
+        </p:nvSpPr>
+        <p:spPr>
+          <a:xfrm>
+            <a:off x="5852160" y="5376672"/>
             <a:ext cx="5029200" cy="347472"/>
           </a:xfrm>
           <a:prstGeom prst="rect">
@@ -1920,29 +1973,29 @@
               <a:buNone/>
             </a:pPr>
             <a:r>
-              <a:rPr lang="en-US" sz="1200" dirty="0">
-                <a:solidFill>
-                  <a:srgbClr val="FFFFFF"/>
-                </a:solidFill>
-                <a:latin typeface="Calibri" pitchFamily="34" charset="0"/>
-                <a:ea typeface="Calibri" pitchFamily="34" charset="-122"/>
-                <a:cs typeface="Calibri" pitchFamily="34" charset="-120"/>
-              </a:rPr>
-              <a:t>Zhumakhan Medet</a:t>
-            </a:r>
-            <a:endParaRPr lang="en-US" sz="1200" dirty="0"/>
-          </a:p>
-        </p:txBody>
-      </p:sp>
-      <p:sp>
-        <p:nvSpPr>
-          <p:cNvPr id="12" name="Text 9"/>
-          <p:cNvSpPr/>
-          <p:nvPr/>
-        </p:nvSpPr>
-        <p:spPr>
-          <a:xfrm>
-            <a:off x="2560320" y="4919472"/>
+              <a:rPr lang="en-US" sz="1100" dirty="0">
+                <a:solidFill>
+                  <a:srgbClr val="1A1A1A"/>
+                </a:solidFill>
+                <a:latin typeface="Calibri" pitchFamily="34" charset="0"/>
+                <a:ea typeface="Calibri" pitchFamily="34" charset="-122"/>
+                <a:cs typeface="Calibri" pitchFamily="34" charset="-120"/>
+              </a:rPr>
+              <a:t>Bektemessov Amanzhol</a:t>
+            </a:r>
+            <a:endParaRPr lang="en-US" sz="1100" dirty="0"/>
+          </a:p>
+        </p:txBody>
+      </p:sp>
+      <p:sp>
+        <p:nvSpPr>
+          <p:cNvPr id="13" name="Text 10"/>
+          <p:cNvSpPr/>
+          <p:nvPr/>
+        </p:nvSpPr>
+        <p:spPr>
+          <a:xfrm>
+            <a:off x="2286000" y="5724144"/>
             <a:ext cx="3383280" cy="347472"/>
           </a:xfrm>
           <a:prstGeom prst="rect">
@@ -1959,7 +2012,7 @@
               <a:buNone/>
             </a:pPr>
             <a:r>
-              <a:rPr lang="en-US" sz="1200" b="1" dirty="0">
+              <a:rPr lang="en-US" sz="1100" b="1" spc="200" kern="0" dirty="0">
                 <a:solidFill>
                   <a:srgbClr val="C9A961"/>
                 </a:solidFill>
@@ -1967,21 +2020,21 @@
                 <a:ea typeface="Calibri" pitchFamily="34" charset="-122"/>
                 <a:cs typeface="Calibri" pitchFamily="34" charset="-120"/>
               </a:rPr>
-              <a:t>Scientific Advisor:</a:t>
-            </a:r>
-            <a:endParaRPr lang="en-US" sz="1200" dirty="0"/>
-          </a:p>
-        </p:txBody>
-      </p:sp>
-      <p:sp>
-        <p:nvSpPr>
-          <p:cNvPr id="13" name="Text 10"/>
-          <p:cNvSpPr/>
-          <p:nvPr/>
-        </p:nvSpPr>
-        <p:spPr>
-          <a:xfrm>
-            <a:off x="6035040" y="4919472"/>
+              <a:t>Educational Program</a:t>
+            </a:r>
+            <a:endParaRPr lang="en-US" sz="1100" dirty="0"/>
+          </a:p>
+        </p:txBody>
+      </p:sp>
+      <p:sp>
+        <p:nvSpPr>
+          <p:cNvPr id="14" name="Text 11"/>
+          <p:cNvSpPr/>
+          <p:nvPr/>
+        </p:nvSpPr>
+        <p:spPr>
+          <a:xfrm>
+            <a:off x="5852160" y="5724144"/>
             <a:ext cx="5029200" cy="347472"/>
           </a:xfrm>
           <a:prstGeom prst="rect">
@@ -1998,29 +2051,29 @@
               <a:buNone/>
             </a:pPr>
             <a:r>
-              <a:rPr lang="en-US" sz="1200" dirty="0">
-                <a:solidFill>
-                  <a:srgbClr val="FFFFFF"/>
-                </a:solidFill>
-                <a:latin typeface="Calibri" pitchFamily="34" charset="0"/>
-                <a:ea typeface="Calibri" pitchFamily="34" charset="-122"/>
-                <a:cs typeface="Calibri" pitchFamily="34" charset="-120"/>
-              </a:rPr>
-              <a:t>Bektemessov Amanzhol</a:t>
-            </a:r>
-            <a:endParaRPr lang="en-US" sz="1200" dirty="0"/>
-          </a:p>
-        </p:txBody>
-      </p:sp>
-      <p:sp>
-        <p:nvSpPr>
-          <p:cNvPr id="14" name="Text 11"/>
-          <p:cNvSpPr/>
-          <p:nvPr/>
-        </p:nvSpPr>
-        <p:spPr>
-          <a:xfrm>
-            <a:off x="2560320" y="5266944"/>
+              <a:rPr lang="en-US" sz="1100" dirty="0">
+                <a:solidFill>
+                  <a:srgbClr val="1A1A1A"/>
+                </a:solidFill>
+                <a:latin typeface="Calibri" pitchFamily="34" charset="0"/>
+                <a:ea typeface="Calibri" pitchFamily="34" charset="-122"/>
+                <a:cs typeface="Calibri" pitchFamily="34" charset="-120"/>
+              </a:rPr>
+              <a:t>7M06116 — Computer Science and Technology</a:t>
+            </a:r>
+            <a:endParaRPr lang="en-US" sz="1100" dirty="0"/>
+          </a:p>
+        </p:txBody>
+      </p:sp>
+      <p:sp>
+        <p:nvSpPr>
+          <p:cNvPr id="15" name="Text 12"/>
+          <p:cNvSpPr/>
+          <p:nvPr/>
+        </p:nvSpPr>
+        <p:spPr>
+          <a:xfrm>
+            <a:off x="2286000" y="6071616"/>
             <a:ext cx="3383280" cy="347472"/>
           </a:xfrm>
           <a:prstGeom prst="rect">
@@ -2037,7 +2090,7 @@
               <a:buNone/>
             </a:pPr>
             <a:r>
-              <a:rPr lang="en-US" sz="1200" b="1" dirty="0">
+              <a:rPr lang="en-US" sz="1100" b="1" spc="200" kern="0" dirty="0">
                 <a:solidFill>
                   <a:srgbClr val="C9A961"/>
                 </a:solidFill>
@@ -2045,21 +2098,21 @@
                 <a:ea typeface="Calibri" pitchFamily="34" charset="-122"/>
                 <a:cs typeface="Calibri" pitchFamily="34" charset="-120"/>
               </a:rPr>
-              <a:t>Educational Program:</a:t>
-            </a:r>
-            <a:endParaRPr lang="en-US" sz="1200" dirty="0"/>
-          </a:p>
-        </p:txBody>
-      </p:sp>
-      <p:sp>
-        <p:nvSpPr>
-          <p:cNvPr id="15" name="Text 12"/>
-          <p:cNvSpPr/>
-          <p:nvPr/>
-        </p:nvSpPr>
-        <p:spPr>
-          <a:xfrm>
-            <a:off x="6035040" y="5266944"/>
+              <a:t>Dataset</a:t>
+            </a:r>
+            <a:endParaRPr lang="en-US" sz="1100" dirty="0"/>
+          </a:p>
+        </p:txBody>
+      </p:sp>
+      <p:sp>
+        <p:nvSpPr>
+          <p:cNvPr id="16" name="Text 13"/>
+          <p:cNvSpPr/>
+          <p:nvPr/>
+        </p:nvSpPr>
+        <p:spPr>
+          <a:xfrm>
+            <a:off x="5852160" y="6071616"/>
             <a:ext cx="5029200" cy="347472"/>
           </a:xfrm>
           <a:prstGeom prst="rect">
@@ -2076,212 +2129,17 @@
               <a:buNone/>
             </a:pPr>
             <a:r>
-              <a:rPr lang="en-US" sz="1200" dirty="0">
-                <a:solidFill>
-                  <a:srgbClr val="FFFFFF"/>
-                </a:solidFill>
-                <a:latin typeface="Calibri" pitchFamily="34" charset="0"/>
-                <a:ea typeface="Calibri" pitchFamily="34" charset="-122"/>
-                <a:cs typeface="Calibri" pitchFamily="34" charset="-120"/>
-              </a:rPr>
-              <a:t>7M06116 — Computer Science and Technology</a:t>
-            </a:r>
-            <a:endParaRPr lang="en-US" sz="1200" dirty="0"/>
-          </a:p>
-        </p:txBody>
-      </p:sp>
-      <p:sp>
-        <p:nvSpPr>
-          <p:cNvPr id="16" name="Text 13"/>
-          <p:cNvSpPr/>
-          <p:nvPr/>
-        </p:nvSpPr>
-        <p:spPr>
-          <a:xfrm>
-            <a:off x="2560320" y="5614416"/>
-            <a:ext cx="3383280" cy="347472"/>
-          </a:xfrm>
-          <a:prstGeom prst="rect">
-            <a:avLst/>
-          </a:prstGeom>
-          <a:noFill/>
-          <a:ln/>
-        </p:spPr>
-        <p:txBody>
-          <a:bodyPr wrap="square" lIns="0" tIns="0" rIns="0" bIns="0" rtlCol="0" anchor="ctr"/>
-          <a:lstStyle/>
-          <a:p>
-            <a:pPr algn="r" indent="0" marL="0">
-              <a:buNone/>
-            </a:pPr>
-            <a:r>
-              <a:rPr lang="en-US" sz="1200" b="1" dirty="0">
-                <a:solidFill>
-                  <a:srgbClr val="C9A961"/>
-                </a:solidFill>
-                <a:latin typeface="Calibri" pitchFamily="34" charset="0"/>
-                <a:ea typeface="Calibri" pitchFamily="34" charset="-122"/>
-                <a:cs typeface="Calibri" pitchFamily="34" charset="-120"/>
-              </a:rPr>
-              <a:t>Dataset:</a:t>
-            </a:r>
-            <a:endParaRPr lang="en-US" sz="1200" dirty="0"/>
-          </a:p>
-        </p:txBody>
-      </p:sp>
-      <p:sp>
-        <p:nvSpPr>
-          <p:cNvPr id="17" name="Text 14"/>
-          <p:cNvSpPr/>
-          <p:nvPr/>
-        </p:nvSpPr>
-        <p:spPr>
-          <a:xfrm>
-            <a:off x="6035040" y="5614416"/>
-            <a:ext cx="5029200" cy="347472"/>
-          </a:xfrm>
-          <a:prstGeom prst="rect">
-            <a:avLst/>
-          </a:prstGeom>
-          <a:noFill/>
-          <a:ln/>
-        </p:spPr>
-        <p:txBody>
-          <a:bodyPr wrap="square" lIns="0" tIns="0" rIns="0" bIns="0" rtlCol="0" anchor="ctr"/>
-          <a:lstStyle/>
-          <a:p>
-            <a:pPr algn="l" indent="0" marL="0">
-              <a:buNone/>
-            </a:pPr>
-            <a:r>
-              <a:rPr lang="en-US" sz="1200" dirty="0">
-                <a:solidFill>
-                  <a:srgbClr val="FFFFFF"/>
-                </a:solidFill>
-                <a:latin typeface="Calibri" pitchFamily="34" charset="0"/>
-                <a:ea typeface="Calibri" pitchFamily="34" charset="-122"/>
-                <a:cs typeface="Calibri" pitchFamily="34" charset="-120"/>
-              </a:rPr>
-              <a:t>Amazon Reviews 2018 Electronics (728K users · 6.7M interactions)</a:t>
-            </a:r>
-            <a:endParaRPr lang="en-US" sz="1200" dirty="0"/>
-          </a:p>
-        </p:txBody>
-      </p:sp>
-      <p:sp>
-        <p:nvSpPr>
-          <p:cNvPr id="18" name="Text 15"/>
-          <p:cNvSpPr/>
-          <p:nvPr/>
-        </p:nvSpPr>
-        <p:spPr>
-          <a:xfrm>
-            <a:off x="2560320" y="5961888"/>
-            <a:ext cx="3383280" cy="347472"/>
-          </a:xfrm>
-          <a:prstGeom prst="rect">
-            <a:avLst/>
-          </a:prstGeom>
-          <a:noFill/>
-          <a:ln/>
-        </p:spPr>
-        <p:txBody>
-          <a:bodyPr wrap="square" lIns="0" tIns="0" rIns="0" bIns="0" rtlCol="0" anchor="ctr"/>
-          <a:lstStyle/>
-          <a:p>
-            <a:pPr algn="r" indent="0" marL="0">
-              <a:buNone/>
-            </a:pPr>
-            <a:r>
-              <a:rPr lang="en-US" sz="1200" b="1" dirty="0">
-                <a:solidFill>
-                  <a:srgbClr val="C9A961"/>
-                </a:solidFill>
-                <a:latin typeface="Calibri" pitchFamily="34" charset="0"/>
-                <a:ea typeface="Calibri" pitchFamily="34" charset="-122"/>
-                <a:cs typeface="Calibri" pitchFamily="34" charset="-120"/>
-              </a:rPr>
-              <a:t>Repository:</a:t>
-            </a:r>
-            <a:endParaRPr lang="en-US" sz="1200" dirty="0"/>
-          </a:p>
-        </p:txBody>
-      </p:sp>
-      <p:sp>
-        <p:nvSpPr>
-          <p:cNvPr id="19" name="Text 16"/>
-          <p:cNvSpPr/>
-          <p:nvPr/>
-        </p:nvSpPr>
-        <p:spPr>
-          <a:xfrm>
-            <a:off x="6035040" y="5961888"/>
-            <a:ext cx="5029200" cy="347472"/>
-          </a:xfrm>
-          <a:prstGeom prst="rect">
-            <a:avLst/>
-          </a:prstGeom>
-          <a:noFill/>
-          <a:ln/>
-        </p:spPr>
-        <p:txBody>
-          <a:bodyPr wrap="square" lIns="0" tIns="0" rIns="0" bIns="0" rtlCol="0" anchor="ctr"/>
-          <a:lstStyle/>
-          <a:p>
-            <a:pPr algn="l" indent="0" marL="0">
-              <a:buNone/>
-            </a:pPr>
-            <a:r>
-              <a:rPr lang="en-US" sz="1200" dirty="0">
-                <a:solidFill>
-                  <a:srgbClr val="FFFFFF"/>
-                </a:solidFill>
-                <a:latin typeface="Calibri" pitchFamily="34" charset="0"/>
-                <a:ea typeface="Calibri" pitchFamily="34" charset="-122"/>
-                <a:cs typeface="Calibri" pitchFamily="34" charset="-120"/>
-              </a:rPr>
-              <a:t>github.com/Medeeet/rec-sys  (MIT License)</a:t>
-            </a:r>
-            <a:endParaRPr lang="en-US" sz="1200" dirty="0"/>
-          </a:p>
-        </p:txBody>
-      </p:sp>
-      <p:sp>
-        <p:nvSpPr>
-          <p:cNvPr id="20" name="Text 17"/>
-          <p:cNvSpPr/>
-          <p:nvPr/>
-        </p:nvSpPr>
-        <p:spPr>
-          <a:xfrm>
-            <a:off x="457200" y="6400800"/>
-            <a:ext cx="11247120" cy="182880"/>
-          </a:xfrm>
-          <a:prstGeom prst="rect">
-            <a:avLst/>
-          </a:prstGeom>
-          <a:noFill/>
-          <a:ln/>
-        </p:spPr>
-        <p:txBody>
-          <a:bodyPr wrap="square" lIns="0" tIns="0" rIns="0" bIns="0" rtlCol="0" anchor="ctr"/>
-          <a:lstStyle/>
-          <a:p>
-            <a:pPr algn="ctr" indent="0" marL="0">
-              <a:buNone/>
-            </a:pPr>
-            <a:r>
-              <a:rPr lang="en-US" sz="900" spc="300" kern="0" dirty="0">
-                <a:solidFill>
-                  <a:srgbClr val="E8D9A8"/>
-                </a:solidFill>
-                <a:latin typeface="Calibri" pitchFamily="34" charset="0"/>
-                <a:ea typeface="Calibri" pitchFamily="34" charset="-122"/>
-                <a:cs typeface="Calibri" pitchFamily="34" charset="-120"/>
-              </a:rPr>
-              <a:t>Pre-Defense  ·  2025-2026 Academic Year  ·  Spring Semester  ·  Almaty</a:t>
-            </a:r>
-            <a:endParaRPr lang="en-US" sz="900" dirty="0"/>
+              <a:rPr lang="en-US" sz="1100" dirty="0">
+                <a:solidFill>
+                  <a:srgbClr val="1A1A1A"/>
+                </a:solidFill>
+                <a:latin typeface="Calibri" pitchFamily="34" charset="0"/>
+                <a:ea typeface="Calibri" pitchFamily="34" charset="-122"/>
+                <a:cs typeface="Calibri" pitchFamily="34" charset="-120"/>
+              </a:rPr>
+              <a:t>Amazon Reviews 2018 Electronics  ·  728K users · 6.7M interactions</a:t>
+            </a:r>
+            <a:endParaRPr lang="en-US" sz="1100" dirty="0"/>
           </a:p>
         </p:txBody>
       </p:sp>

</xml_diff>